<commit_message>
[2026-06-26 22:09] refactor: remove unused modules, simplify codebase, move resources to res/, add VSCode launch config, update design docs
</commit_message>
<xml_diff>
--- a/jira_export_pptx.pptx
+++ b/jira_export_pptx.pptx
@@ -12,8 +12,7 @@
   </p:handoutMasterIdLst>
   <p:sldIdLst>
     <p:sldId id="1248" r:id="rId2"/>
-    <p:sldId id="1397" r:id="rId3"/>
-    <p:sldId id="1399" r:id="rId4"/>
+    <p:sldId id="1400" r:id="rId15"/>
   </p:sldIdLst>
   <p:sldSz cx="24384000" cy="13716000"/>
   <p:notesSz cx="6858000" cy="9144000"/>
@@ -17193,7 +17192,7 @@
           <p:nvPr>
             <p:extLst>
               <p:ext uri="{D42A27DB-BD31-4B8C-83A1-F6EECF244321}">
-                <p14:modId xmlns:p14="http://schemas.microsoft.com/office/powerpoint/2010/main" val="15166237"/>
+                <p14:modId xmlns:p14="http://schemas.microsoft.com/office/powerpoint/2010/main" val="2799925240"/>
               </p:ext>
             </p:extLst>
           </p:nvPr>
@@ -17227,24 +17226,7 @@
                   <a:txBody>
                     <a:bodyPr/>
                     <a:lstStyle/>
-                    <a:p>
-                      <a:pPr algn="ctr">
-                        <a:buNone/>
-                      </a:pPr>
-                      <a:r>
-                        <a:rPr lang="en-US" sz="3600">
-                          <a:latin typeface="Calibri" panose="020F0502020204030204" pitchFamily="34" charset="0"/>
-                          <a:ea typeface="Calibri" panose="020F0502020204030204" pitchFamily="34" charset="0"/>
-                          <a:cs typeface="Calibri" panose="020F0502020204030204" pitchFamily="34" charset="0"/>
-                        </a:rPr>
-                        <a:t>MODULE</a:t>
-                      </a:r>
-                      <a:endParaRPr lang="en-US" sz="3600" dirty="0">
-                        <a:latin typeface="Calibri" panose="020F0502020204030204" pitchFamily="34" charset="0"/>
-                        <a:ea typeface="Calibri" panose="020F0502020204030204" pitchFamily="34" charset="0"/>
-                        <a:cs typeface="Calibri" panose="020F0502020204030204" pitchFamily="34" charset="0"/>
-                      </a:endParaRPr>
-                    </a:p>
+                    <a:p/>
                   </a:txBody>
                   <a:tcPr marL="23070" marR="23070" marT="11535" marB="11535" anchor="ctr">
                     <a:lnL w="12700" cap="flat" cmpd="sng" algn="ctr">
@@ -17291,46 +17273,9 @@
                     <a:bodyPr/>
                     <a:lstStyle/>
                     <a:p>
-                      <a:pPr marL="0" marR="0" lvl="0" indent="0" algn="ctr" defTabSz="1172210" eaLnBrk="1" fontAlgn="auto" latinLnBrk="0" hangingPunct="1">
-                        <a:lnSpc>
-                          <a:spcPct val="100000"/>
-                        </a:lnSpc>
-                        <a:spcBef>
-                          <a:spcPts val="0"/>
-                        </a:spcBef>
-                        <a:spcAft>
-                          <a:spcPts val="0"/>
-                        </a:spcAft>
-                        <a:buClrTx/>
-                        <a:buSzTx/>
-                        <a:buFontTx/>
-                        <a:buNone/>
-                        <a:tabLst/>
-                        <a:defRPr/>
-                      </a:pPr>
                       <a:r>
-                        <a:rPr lang="en-GB" altLang="zh-CN" sz="3600" b="0" i="0" u="none" strike="noStrike" cap="none" spc="0" baseline="0" dirty="0">
-                          <a:solidFill>
-                            <a:schemeClr val="tx1"/>
-                          </a:solidFill>
-                          <a:uFillTx/>
-                          <a:latin typeface="Calibri" panose="020F0502020204030204" pitchFamily="34" charset="0"/>
-                          <a:ea typeface="Calibri" panose="020F0502020204030204" pitchFamily="34" charset="0"/>
-                          <a:cs typeface="Calibri" panose="020F0502020204030204" pitchFamily="34" charset="0"/>
-                          <a:sym typeface="Helvetica"/>
-                        </a:rPr>
-                        <a:t>ID</a:t>
+                        <a:t>VEL-16399</a:t>
                       </a:r>
-                      <a:endParaRPr lang="en-US" altLang="zh-CN" sz="3600" b="0" i="0" u="none" strike="noStrike" cap="none" spc="0" baseline="0" dirty="0">
-                        <a:solidFill>
-                          <a:schemeClr val="tx1"/>
-                        </a:solidFill>
-                        <a:uFillTx/>
-                        <a:latin typeface="Calibri" panose="020F0502020204030204" pitchFamily="34" charset="0"/>
-                        <a:ea typeface="Calibri" panose="020F0502020204030204" pitchFamily="34" charset="0"/>
-                        <a:cs typeface="Calibri" panose="020F0502020204030204" pitchFamily="34" charset="0"/>
-                        <a:sym typeface="Helvetica"/>
-                      </a:endParaRPr>
                     </a:p>
                   </a:txBody>
                   <a:tcPr marL="23070" marR="23070" marT="11535" marB="11535" anchor="ctr">
@@ -17379,163 +17324,6 @@
                   </a:ext>
                 </a:extLst>
               </a:tr>
-              <a:tr h="1267555">
-                <a:tc>
-                  <a:txBody>
-                    <a:bodyPr/>
-                    <a:lstStyle/>
-                    <a:p>
-                      <a:pPr algn="ctr">
-                        <a:buNone/>
-                      </a:pPr>
-                      <a:r>
-                        <a:rPr lang="en-US" sz="3600">
-                          <a:latin typeface="Calibri" panose="020F0502020204030204" pitchFamily="34" charset="0"/>
-                          <a:ea typeface="Calibri" panose="020F0502020204030204" pitchFamily="34" charset="0"/>
-                          <a:cs typeface="Calibri" panose="020F0502020204030204" pitchFamily="34" charset="0"/>
-                        </a:rPr>
-                        <a:t>TBT</a:t>
-                      </a:r>
-                      <a:endParaRPr lang="en-US" sz="3600" dirty="0">
-                        <a:latin typeface="Calibri" panose="020F0502020204030204" pitchFamily="34" charset="0"/>
-                        <a:ea typeface="Calibri" panose="020F0502020204030204" pitchFamily="34" charset="0"/>
-                        <a:cs typeface="Calibri" panose="020F0502020204030204" pitchFamily="34" charset="0"/>
-                      </a:endParaRPr>
-                    </a:p>
-                  </a:txBody>
-                  <a:tcPr marL="23070" marR="23070" marT="11535" marB="11535" anchor="ctr">
-                    <a:lnL w="12700" cap="flat" cmpd="sng" algn="ctr">
-                      <a:solidFill>
-                        <a:schemeClr val="tx1"/>
-                      </a:solidFill>
-                      <a:prstDash val="solid"/>
-                      <a:round/>
-                      <a:headEnd type="none" w="med" len="med"/>
-                      <a:tailEnd type="none" w="med" len="med"/>
-                    </a:lnL>
-                    <a:lnR w="12700" cap="flat" cmpd="sng" algn="ctr">
-                      <a:solidFill>
-                        <a:schemeClr val="tx1"/>
-                      </a:solidFill>
-                      <a:prstDash val="solid"/>
-                      <a:round/>
-                      <a:headEnd type="none" w="med" len="med"/>
-                      <a:tailEnd type="none" w="med" len="med"/>
-                    </a:lnR>
-                    <a:lnT w="12700" cap="flat" cmpd="sng" algn="ctr">
-                      <a:solidFill>
-                        <a:schemeClr val="tx1"/>
-                      </a:solidFill>
-                      <a:prstDash val="solid"/>
-                      <a:round/>
-                      <a:headEnd type="none" w="med" len="med"/>
-                      <a:tailEnd type="none" w="med" len="med"/>
-                    </a:lnT>
-                    <a:lnB w="12700" cap="flat" cmpd="sng" algn="ctr">
-                      <a:solidFill>
-                        <a:schemeClr val="tx1"/>
-                      </a:solidFill>
-                      <a:prstDash val="solid"/>
-                      <a:round/>
-                      <a:headEnd type="none" w="med" len="med"/>
-                      <a:tailEnd type="none" w="med" len="med"/>
-                    </a:lnB>
-                    <a:noFill/>
-                  </a:tcPr>
-                </a:tc>
-                <a:tc>
-                  <a:txBody>
-                    <a:bodyPr/>
-                    <a:lstStyle/>
-                    <a:p>
-                      <a:pPr marL="0" marR="0" lvl="0" indent="0" algn="ctr" defTabSz="1172210" eaLnBrk="1" fontAlgn="auto" latinLnBrk="0" hangingPunct="1">
-                        <a:lnSpc>
-                          <a:spcPct val="100000"/>
-                        </a:lnSpc>
-                        <a:spcBef>
-                          <a:spcPts val="0"/>
-                        </a:spcBef>
-                        <a:spcAft>
-                          <a:spcPts val="0"/>
-                        </a:spcAft>
-                        <a:buClrTx/>
-                        <a:buSzTx/>
-                        <a:buFontTx/>
-                        <a:buNone/>
-                        <a:tabLst/>
-                        <a:defRPr/>
-                      </a:pPr>
-                      <a:r>
-                        <a:rPr lang="en-US" altLang="zh-CN" sz="3600" b="0" i="0" u="none" strike="noStrike" cap="none" spc="0" baseline="0">
-                          <a:solidFill>
-                            <a:schemeClr val="tx1"/>
-                          </a:solidFill>
-                          <a:uFillTx/>
-                          <a:latin typeface="Calibri" panose="020F0502020204030204" pitchFamily="34" charset="0"/>
-                          <a:ea typeface="Calibri" panose="020F0502020204030204" pitchFamily="34" charset="0"/>
-                          <a:cs typeface="Calibri" panose="020F0502020204030204" pitchFamily="34" charset="0"/>
-                          <a:sym typeface="Helvetica"/>
-                        </a:rPr>
-                        <a:t>VEL-16399</a:t>
-                      </a:r>
-                      <a:endParaRPr lang="en-US" altLang="zh-CN" sz="3600" b="0" i="0" u="none" strike="noStrike" cap="none" spc="0" baseline="0" dirty="0">
-                        <a:solidFill>
-                          <a:schemeClr val="tx1"/>
-                        </a:solidFill>
-                        <a:uFillTx/>
-                        <a:latin typeface="Calibri" panose="020F0502020204030204" pitchFamily="34" charset="0"/>
-                        <a:ea typeface="Calibri" panose="020F0502020204030204" pitchFamily="34" charset="0"/>
-                        <a:cs typeface="Calibri" panose="020F0502020204030204" pitchFamily="34" charset="0"/>
-                        <a:sym typeface="Helvetica"/>
-                      </a:endParaRPr>
-                    </a:p>
-                  </a:txBody>
-                  <a:tcPr marL="23070" marR="23070" marT="11535" marB="11535" anchor="ctr">
-                    <a:lnL w="12700" cap="flat" cmpd="sng" algn="ctr">
-                      <a:solidFill>
-                        <a:schemeClr val="tx1"/>
-                      </a:solidFill>
-                      <a:prstDash val="solid"/>
-                      <a:round/>
-                      <a:headEnd type="none" w="med" len="med"/>
-                      <a:tailEnd type="none" w="med" len="med"/>
-                    </a:lnL>
-                    <a:lnR w="12700" cap="flat" cmpd="sng" algn="ctr">
-                      <a:solidFill>
-                        <a:schemeClr val="tx1"/>
-                      </a:solidFill>
-                      <a:prstDash val="solid"/>
-                      <a:round/>
-                      <a:headEnd type="none" w="med" len="med"/>
-                      <a:tailEnd type="none" w="med" len="med"/>
-                    </a:lnR>
-                    <a:lnT w="12700" cap="flat" cmpd="sng" algn="ctr">
-                      <a:solidFill>
-                        <a:schemeClr val="tx1"/>
-                      </a:solidFill>
-                      <a:prstDash val="solid"/>
-                      <a:round/>
-                      <a:headEnd type="none" w="med" len="med"/>
-                      <a:tailEnd type="none" w="med" len="med"/>
-                    </a:lnT>
-                    <a:lnB w="12700" cap="flat" cmpd="sng" algn="ctr">
-                      <a:solidFill>
-                        <a:schemeClr val="tx1"/>
-                      </a:solidFill>
-                      <a:prstDash val="solid"/>
-                      <a:round/>
-                      <a:headEnd type="none" w="med" len="med"/>
-                      <a:tailEnd type="none" w="med" len="med"/>
-                    </a:lnB>
-                    <a:noFill/>
-                  </a:tcPr>
-                </a:tc>
-                <a:extLst>
-                  <a:ext uri="{0D108BD9-81ED-4DB2-BD59-A6C34878D82A}">
-                    <a16:rowId xmlns:a16="http://schemas.microsoft.com/office/drawing/2014/main" val="2032611438"/>
-                  </a:ext>
-                </a:extLst>
-              </a:tr>
             </a:tbl>
           </a:graphicData>
         </a:graphic>
@@ -17549,35 +17337,22 @@
 </p:sld>
 </file>
 
-<file path=ppt/slides/slide2.xml><?xml version="1.0" encoding="utf-8"?>
-<p:sld xmlns:a="http://schemas.openxmlformats.org/drawingml/2006/main" xmlns:r="http://schemas.openxmlformats.org/officeDocument/2006/relationships" xmlns:p="http://schemas.openxmlformats.org/presentationml/2006/main">
+<file path=ppt/slides/slide4.xml><?xml version="1.0" encoding="utf-8"?>
+<p:sld xmlns:a="http://schemas.openxmlformats.org/drawingml/2006/main" xmlns:p="http://schemas.openxmlformats.org/presentationml/2006/main" xmlns:r="http://schemas.openxmlformats.org/officeDocument/2006/relationships">
   <p:cSld>
     <p:spTree>
       <p:nvGrpSpPr>
-        <p:cNvPr id="1" name="">
-          <a:extLst>
-            <a:ext uri="{FF2B5EF4-FFF2-40B4-BE49-F238E27FC236}">
-              <a16:creationId xmlns:a16="http://schemas.microsoft.com/office/drawing/2014/main" id="{10B409B7-18A1-5F4C-B50B-3E029AB5A19D}"/>
-            </a:ext>
-          </a:extLst>
-        </p:cNvPr>
+        <p:cNvPr id="1" name=""/>
         <p:cNvGrpSpPr/>
         <p:nvPr/>
       </p:nvGrpSpPr>
-      <p:grpSpPr>
-        <a:xfrm>
-          <a:off x="0" y="0"/>
-          <a:ext cx="0" cy="0"/>
-          <a:chOff x="0" y="0"/>
-          <a:chExt cx="0" cy="0"/>
-        </a:xfrm>
-      </p:grpSpPr>
+      <p:grpSpPr/>
       <p:sp>
         <p:nvSpPr>
           <p:cNvPr id="12" name="文本框 6">
             <a:extLst>
               <a:ext uri="{FF2B5EF4-FFF2-40B4-BE49-F238E27FC236}">
-                <a16:creationId xmlns:a16="http://schemas.microsoft.com/office/drawing/2014/main" id="{2F81EB46-9EDB-5FF6-CED6-5CE9299C3526}"/>
+                <a16:creationId xmlns:a16="http://schemas.microsoft.com/office/drawing/2014/main" id="{C616AC37-0582-BEC0-6E99-71ADFF557283}"/>
               </a:ext>
             </a:extLst>
           </p:cNvPr>
@@ -17623,7 +17398,7 @@
           <a:p>
             <a:pPr algn="l"/>
             <a:r>
-              <a:rPr lang="en-US" altLang="zh-CN" sz="3200">
+              <a:rPr lang="en-US" altLang="zh-CN" sz="3200" dirty="0">
                 <a:solidFill>
                   <a:schemeClr val="tx2"/>
                 </a:solidFill>
@@ -17631,78 +17406,22 @@
                 <a:ea typeface="Calibri" panose="020F0502020204030204" pitchFamily="34" charset="0"/>
                 <a:cs typeface="Calibri" panose="020F0502020204030204" pitchFamily="34" charset="0"/>
               </a:rPr>
-              <a:t>VEL-16399 【#2(Toyota)】【DN】【Animation】【745D】【</a:t>
-            </a:r>
-            <a:r>
-              <a:rPr lang="zh-CN" altLang="en-US" sz="3200">
-                <a:solidFill>
-                  <a:schemeClr val="tx2"/>
-                </a:solidFill>
-                <a:latin typeface="Calibri" panose="020F0502020204030204" pitchFamily="34" charset="0"/>
-                <a:ea typeface="Calibri" panose="020F0502020204030204" pitchFamily="34" charset="0"/>
-                <a:cs typeface="Calibri" panose="020F0502020204030204" pitchFamily="34" charset="0"/>
-              </a:rPr>
-              <a:t>新增功能</a:t>
-            </a:r>
-            <a:r>
-              <a:rPr lang="en-US" altLang="zh-CN" sz="3200">
-                <a:solidFill>
-                  <a:schemeClr val="tx2"/>
-                </a:solidFill>
-                <a:latin typeface="Calibri" panose="020F0502020204030204" pitchFamily="34" charset="0"/>
-                <a:ea typeface="Calibri" panose="020F0502020204030204" pitchFamily="34" charset="0"/>
-                <a:cs typeface="Calibri" panose="020F0502020204030204" pitchFamily="34" charset="0"/>
-              </a:rPr>
-              <a:t>】</a:t>
-            </a:r>
-            <a:r>
-              <a:rPr lang="zh-CN" altLang="en-US" sz="3200">
-                <a:solidFill>
-                  <a:schemeClr val="tx2"/>
-                </a:solidFill>
-                <a:latin typeface="Calibri" panose="020F0502020204030204" pitchFamily="34" charset="0"/>
-                <a:ea typeface="Calibri" panose="020F0502020204030204" pitchFamily="34" charset="0"/>
-                <a:cs typeface="Calibri" panose="020F0502020204030204" pitchFamily="34" charset="0"/>
-              </a:rPr>
-              <a:t>新增</a:t>
-            </a:r>
-            <a:r>
-              <a:rPr lang="en-US" altLang="zh-CN" sz="3200">
-                <a:solidFill>
-                  <a:schemeClr val="tx2"/>
-                </a:solidFill>
-                <a:latin typeface="Calibri" panose="020F0502020204030204" pitchFamily="34" charset="0"/>
-                <a:ea typeface="Calibri" panose="020F0502020204030204" pitchFamily="34" charset="0"/>
-                <a:cs typeface="Calibri" panose="020F0502020204030204" pitchFamily="34" charset="0"/>
-              </a:rPr>
-              <a:t>Normal Display - Battery Status</a:t>
-            </a:r>
-            <a:r>
-              <a:rPr lang="zh-CN" altLang="en-US" sz="3200">
-                <a:solidFill>
-                  <a:schemeClr val="tx2"/>
-                </a:solidFill>
-                <a:latin typeface="Calibri" panose="020F0502020204030204" pitchFamily="34" charset="0"/>
-                <a:ea typeface="Calibri" panose="020F0502020204030204" pitchFamily="34" charset="0"/>
-                <a:cs typeface="Calibri" panose="020F0502020204030204" pitchFamily="34" charset="0"/>
-              </a:rPr>
-              <a:t>功能 动效对应</a:t>
-            </a:r>
-            <a:endParaRPr lang="zh-CN" altLang="en-US" sz="3200" dirty="0">
+              <a:t>VEL-16399 【#2(Toyota)】【DN】【Animation】【745D】【新增功能】新增Normal Display - Battery Status功能 动效对应</a:t>
+            </a:r>
+            <a:endParaRPr lang="zh-CN" altLang="en-US" sz="3200" b="1" dirty="0">
               <a:solidFill>
                 <a:schemeClr val="tx2"/>
               </a:solidFill>
-              <a:latin typeface="Calibri" panose="020F0502020204030204" pitchFamily="34" charset="0"/>
             </a:endParaRPr>
           </a:p>
         </p:txBody>
       </p:sp>
       <p:sp>
         <p:nvSpPr>
-          <p:cNvPr id="8" name="文本框 7">
+          <p:cNvPr id="4" name="文本框 3">
             <a:extLst>
               <a:ext uri="{FF2B5EF4-FFF2-40B4-BE49-F238E27FC236}">
-                <a16:creationId xmlns:a16="http://schemas.microsoft.com/office/drawing/2014/main" id="{2CDABD5C-C070-31E0-4701-C7E6BC6E95AE}"/>
+                <a16:creationId xmlns:a16="http://schemas.microsoft.com/office/drawing/2014/main" id="{33C83B96-6DD2-8EA4-60C9-11D67C7E21CD}"/>
               </a:ext>
             </a:extLst>
           </p:cNvPr>
@@ -17711,8 +17430,8 @@
         </p:nvSpPr>
         <p:spPr>
           <a:xfrm>
-            <a:off x="649605" y="1277620"/>
-            <a:ext cx="1700787" cy="1087477"/>
+            <a:off x="12673440" y="1272978"/>
+            <a:ext cx="6530634" cy="1087477"/>
           </a:xfrm>
           <a:prstGeom prst="rect">
             <a:avLst/>
@@ -17745,7 +17464,7 @@
               <a:defRPr/>
             </a:pPr>
             <a:r>
-              <a:rPr lang="en-US" altLang="zh-CN" sz="6400">
+              <a:rPr lang="en-US" altLang="zh-CN" sz="6400" dirty="0">
                 <a:solidFill>
                   <a:srgbClr val="434343">
                     <a:lumMod val="50000"/>
@@ -17754,56 +17473,17 @@
                 <a:latin typeface="Meiryo UI" panose="020B0604030504040204" pitchFamily="34" charset="-128"/>
                 <a:ea typeface="Meiryo UI" panose="020B0604030504040204" pitchFamily="34" charset="-128"/>
               </a:rPr>
-              <a:t>TBT</a:t>
-            </a:r>
-            <a:endParaRPr lang="en-US" altLang="zh-CN" sz="6400" dirty="0">
-              <a:solidFill>
-                <a:srgbClr val="434343">
-                  <a:lumMod val="50000"/>
-                </a:srgbClr>
-              </a:solidFill>
-              <a:latin typeface="Meiryo UI" panose="020B0604030504040204" pitchFamily="34" charset="-128"/>
-              <a:ea typeface="Meiryo UI" panose="020B0604030504040204" pitchFamily="34" charset="-128"/>
-            </a:endParaRPr>
-          </a:p>
-        </p:txBody>
-      </p:sp>
-      <p:pic>
-        <p:nvPicPr>
-          <p:cNvPr id="3" name="图片 2">
+              <a:t/>
+            </a:r>
+          </a:p>
+        </p:txBody>
+      </p:sp>
+      <p:sp>
+        <p:nvSpPr>
+          <p:cNvPr id="2" name="文本框 1">
             <a:extLst>
               <a:ext uri="{FF2B5EF4-FFF2-40B4-BE49-F238E27FC236}">
-                <a16:creationId xmlns:a16="http://schemas.microsoft.com/office/drawing/2014/main" id="{908285EE-4D6B-A318-F168-9BB973F7FBB7}"/>
-              </a:ext>
-            </a:extLst>
-          </p:cNvPr>
-          <p:cNvPicPr>
-            <a:picLocks noChangeAspect="1"/>
-          </p:cNvPicPr>
-          <p:nvPr/>
-        </p:nvPicPr>
-        <p:blipFill>
-          <a:blip r:embed="rId2"/>
-          <a:stretch>
-            <a:fillRect/>
-          </a:stretch>
-        </p:blipFill>
-        <p:spPr>
-          <a:xfrm>
-            <a:off x="4807129" y="5540348"/>
-            <a:ext cx="15187492" cy="4822852"/>
-          </a:xfrm>
-          <a:prstGeom prst="rect">
-            <a:avLst/>
-          </a:prstGeom>
-        </p:spPr>
-      </p:pic>
-      <p:sp>
-        <p:nvSpPr>
-          <p:cNvPr id="4" name="文本框 3">
-            <a:extLst>
-              <a:ext uri="{FF2B5EF4-FFF2-40B4-BE49-F238E27FC236}">
-                <a16:creationId xmlns:a16="http://schemas.microsoft.com/office/drawing/2014/main" id="{42012226-633A-1A58-4358-728B9A687A3F}"/>
+                <a16:creationId xmlns:a16="http://schemas.microsoft.com/office/drawing/2014/main" id="{98AA5B65-BF3C-37BA-BBFF-E961FA80168C}"/>
               </a:ext>
             </a:extLst>
           </p:cNvPr>
@@ -17812,8 +17492,8 @@
         </p:nvSpPr>
         <p:spPr>
           <a:xfrm>
-            <a:off x="12673440" y="1272978"/>
-            <a:ext cx="3342262" cy="1087477"/>
+            <a:off x="649605" y="1277620"/>
+            <a:ext cx="3683701" cy="1087477"/>
           </a:xfrm>
           <a:prstGeom prst="rect">
             <a:avLst/>
@@ -17846,239 +17526,6 @@
               <a:defRPr/>
             </a:pPr>
             <a:r>
-              <a:rPr lang="en-US" altLang="zh-CN" sz="6400">
-                <a:solidFill>
-                  <a:srgbClr val="434343">
-                    <a:lumMod val="50000"/>
-                  </a:srgbClr>
-                </a:solidFill>
-                <a:latin typeface="Meiryo UI" panose="020B0604030504040204" pitchFamily="34" charset="-128"/>
-                <a:ea typeface="Meiryo UI" panose="020B0604030504040204" pitchFamily="34" charset="-128"/>
-              </a:rPr>
-              <a:t>Solution</a:t>
-            </a:r>
-            <a:endParaRPr lang="en-US" altLang="zh-CN" sz="6400" dirty="0">
-              <a:solidFill>
-                <a:srgbClr val="434343">
-                  <a:lumMod val="50000"/>
-                </a:srgbClr>
-              </a:solidFill>
-              <a:latin typeface="Meiryo UI" panose="020B0604030504040204" pitchFamily="34" charset="-128"/>
-              <a:ea typeface="Meiryo UI" panose="020B0604030504040204" pitchFamily="34" charset="-128"/>
-            </a:endParaRPr>
-          </a:p>
-        </p:txBody>
-      </p:sp>
-    </p:spTree>
-    <p:extLst>
-      <p:ext uri="{BB962C8B-B14F-4D97-AF65-F5344CB8AC3E}">
-        <p14:creationId xmlns:p14="http://schemas.microsoft.com/office/powerpoint/2010/main" val="3807112921"/>
-      </p:ext>
-    </p:extLst>
-  </p:cSld>
-  <p:clrMapOvr>
-    <a:masterClrMapping/>
-  </p:clrMapOvr>
-  <p:transition spd="med"/>
-</p:sld>
-</file>
-
-<file path=ppt/slides/slide3.xml><?xml version="1.0" encoding="utf-8"?>
-<p:sld xmlns:a="http://schemas.openxmlformats.org/drawingml/2006/main" xmlns:r="http://schemas.openxmlformats.org/officeDocument/2006/relationships" xmlns:p="http://schemas.openxmlformats.org/presentationml/2006/main">
-  <p:cSld>
-    <p:spTree>
-      <p:nvGrpSpPr>
-        <p:cNvPr id="1" name="">
-          <a:extLst>
-            <a:ext uri="{FF2B5EF4-FFF2-40B4-BE49-F238E27FC236}">
-              <a16:creationId xmlns:a16="http://schemas.microsoft.com/office/drawing/2014/main" id="{F6F542D9-AE88-706F-0735-25E661F97D9A}"/>
-            </a:ext>
-          </a:extLst>
-        </p:cNvPr>
-        <p:cNvGrpSpPr/>
-        <p:nvPr/>
-      </p:nvGrpSpPr>
-      <p:grpSpPr>
-        <a:xfrm>
-          <a:off x="0" y="0"/>
-          <a:ext cx="0" cy="0"/>
-          <a:chOff x="0" y="0"/>
-          <a:chExt cx="0" cy="0"/>
-        </a:xfrm>
-      </p:grpSpPr>
-      <p:sp>
-        <p:nvSpPr>
-          <p:cNvPr id="12" name="文本框 6">
-            <a:extLst>
-              <a:ext uri="{FF2B5EF4-FFF2-40B4-BE49-F238E27FC236}">
-                <a16:creationId xmlns:a16="http://schemas.microsoft.com/office/drawing/2014/main" id="{C616AC37-0582-BEC0-6E99-71ADFF557283}"/>
-              </a:ext>
-            </a:extLst>
-          </p:cNvPr>
-          <p:cNvSpPr txBox="1"/>
-          <p:nvPr/>
-        </p:nvSpPr>
-        <p:spPr>
-          <a:xfrm>
-            <a:off x="294957" y="2716035"/>
-            <a:ext cx="23794085" cy="1891134"/>
-          </a:xfrm>
-          <a:prstGeom prst="rect">
-            <a:avLst/>
-          </a:prstGeom>
-          <a:solidFill>
-            <a:schemeClr val="accent1">
-              <a:lumMod val="40000"/>
-              <a:lumOff val="60000"/>
-            </a:schemeClr>
-          </a:solidFill>
-          <a:ln w="12700" cap="flat">
-            <a:noFill/>
-            <a:miter lim="400000"/>
-          </a:ln>
-        </p:spPr>
-        <p:style>
-          <a:lnRef idx="0">
-            <a:scrgbClr r="0" g="0" b="0"/>
-          </a:lnRef>
-          <a:fillRef idx="0">
-            <a:scrgbClr r="0" g="0" b="0"/>
-          </a:fillRef>
-          <a:effectRef idx="0">
-            <a:scrgbClr r="0" g="0" b="0"/>
-          </a:effectRef>
-          <a:fontRef idx="none"/>
-        </p:style>
-        <p:txBody>
-          <a:bodyPr rot="0" vertOverflow="overflow" horzOverflow="overflow" vert="horz" wrap="square" lIns="50800" tIns="50800" rIns="50800" bIns="50800" numCol="1" spcCol="38100" rtlCol="0" anchor="ctr" forceAA="0">
-            <a:noAutofit/>
-          </a:bodyPr>
-          <a:lstStyle/>
-          <a:p>
-            <a:pPr algn="l"/>
-            <a:r>
-              <a:rPr lang="en-US" altLang="zh-CN" sz="3200">
-                <a:solidFill>
-                  <a:schemeClr val="tx2"/>
-                </a:solidFill>
-                <a:latin typeface="Calibri" panose="020F0502020204030204" pitchFamily="34" charset="0"/>
-                <a:ea typeface="Calibri" panose="020F0502020204030204" pitchFamily="34" charset="0"/>
-                <a:cs typeface="Calibri" panose="020F0502020204030204" pitchFamily="34" charset="0"/>
-              </a:rPr>
-              <a:t>VEL-16399 【#2(Toyota)】【DN】【Animation】【745D】【</a:t>
-            </a:r>
-            <a:r>
-              <a:rPr lang="zh-CN" altLang="en-US" sz="3200">
-                <a:solidFill>
-                  <a:schemeClr val="tx2"/>
-                </a:solidFill>
-                <a:latin typeface="Calibri" panose="020F0502020204030204" pitchFamily="34" charset="0"/>
-                <a:ea typeface="Calibri" panose="020F0502020204030204" pitchFamily="34" charset="0"/>
-                <a:cs typeface="Calibri" panose="020F0502020204030204" pitchFamily="34" charset="0"/>
-              </a:rPr>
-              <a:t>新增功能</a:t>
-            </a:r>
-            <a:r>
-              <a:rPr lang="en-US" altLang="zh-CN" sz="3200">
-                <a:solidFill>
-                  <a:schemeClr val="tx2"/>
-                </a:solidFill>
-                <a:latin typeface="Calibri" panose="020F0502020204030204" pitchFamily="34" charset="0"/>
-                <a:ea typeface="Calibri" panose="020F0502020204030204" pitchFamily="34" charset="0"/>
-                <a:cs typeface="Calibri" panose="020F0502020204030204" pitchFamily="34" charset="0"/>
-              </a:rPr>
-              <a:t>】</a:t>
-            </a:r>
-            <a:r>
-              <a:rPr lang="zh-CN" altLang="en-US" sz="3200">
-                <a:solidFill>
-                  <a:schemeClr val="tx2"/>
-                </a:solidFill>
-                <a:latin typeface="Calibri" panose="020F0502020204030204" pitchFamily="34" charset="0"/>
-                <a:ea typeface="Calibri" panose="020F0502020204030204" pitchFamily="34" charset="0"/>
-                <a:cs typeface="Calibri" panose="020F0502020204030204" pitchFamily="34" charset="0"/>
-              </a:rPr>
-              <a:t>新增</a:t>
-            </a:r>
-            <a:r>
-              <a:rPr lang="en-US" altLang="zh-CN" sz="3200">
-                <a:solidFill>
-                  <a:schemeClr val="tx2"/>
-                </a:solidFill>
-                <a:latin typeface="Calibri" panose="020F0502020204030204" pitchFamily="34" charset="0"/>
-                <a:ea typeface="Calibri" panose="020F0502020204030204" pitchFamily="34" charset="0"/>
-                <a:cs typeface="Calibri" panose="020F0502020204030204" pitchFamily="34" charset="0"/>
-              </a:rPr>
-              <a:t>Normal Display - Battery Status</a:t>
-            </a:r>
-            <a:r>
-              <a:rPr lang="zh-CN" altLang="en-US" sz="3200">
-                <a:solidFill>
-                  <a:schemeClr val="tx2"/>
-                </a:solidFill>
-                <a:latin typeface="Calibri" panose="020F0502020204030204" pitchFamily="34" charset="0"/>
-                <a:ea typeface="Calibri" panose="020F0502020204030204" pitchFamily="34" charset="0"/>
-                <a:cs typeface="Calibri" panose="020F0502020204030204" pitchFamily="34" charset="0"/>
-              </a:rPr>
-              <a:t>功能 动效对应</a:t>
-            </a:r>
-            <a:endParaRPr lang="zh-CN" altLang="en-US" sz="3200" dirty="0">
-              <a:solidFill>
-                <a:schemeClr val="tx2"/>
-              </a:solidFill>
-              <a:latin typeface="Calibri" panose="020F0502020204030204" pitchFamily="34" charset="0"/>
-            </a:endParaRPr>
-          </a:p>
-        </p:txBody>
-      </p:sp>
-      <p:sp>
-        <p:nvSpPr>
-          <p:cNvPr id="4" name="文本框 3">
-            <a:extLst>
-              <a:ext uri="{FF2B5EF4-FFF2-40B4-BE49-F238E27FC236}">
-                <a16:creationId xmlns:a16="http://schemas.microsoft.com/office/drawing/2014/main" id="{33C83B96-6DD2-8EA4-60C9-11D67C7E21CD}"/>
-              </a:ext>
-            </a:extLst>
-          </p:cNvPr>
-          <p:cNvSpPr txBox="1"/>
-          <p:nvPr/>
-        </p:nvSpPr>
-        <p:spPr>
-          <a:xfrm>
-            <a:off x="12673440" y="1272978"/>
-            <a:ext cx="6530634" cy="1087477"/>
-          </a:xfrm>
-          <a:prstGeom prst="rect">
-            <a:avLst/>
-          </a:prstGeom>
-          <a:noFill/>
-          <a:ln w="12700" cap="flat">
-            <a:noFill/>
-            <a:miter lim="400000"/>
-          </a:ln>
-        </p:spPr>
-        <p:style>
-          <a:lnRef idx="0">
-            <a:scrgbClr r="0" g="0" b="0"/>
-          </a:lnRef>
-          <a:fillRef idx="0">
-            <a:scrgbClr r="0" g="0" b="0"/>
-          </a:fillRef>
-          <a:effectRef idx="0">
-            <a:scrgbClr r="0" g="0" b="0"/>
-          </a:effectRef>
-          <a:fontRef idx="none"/>
-        </p:style>
-        <p:txBody>
-          <a:bodyPr rot="0" vertOverflow="overflow" horzOverflow="overflow" vert="horz" wrap="none" lIns="50800" tIns="50800" rIns="50800" bIns="50800" numCol="1" spcCol="38100" rtlCol="0" anchor="t" forceAA="0">
-            <a:spAutoFit/>
-          </a:bodyPr>
-          <a:lstStyle/>
-          <a:p>
-            <a:pPr lvl="0" algn="l">
-              <a:defRPr/>
-            </a:pPr>
-            <a:r>
               <a:rPr lang="en-US" altLang="zh-CN" sz="6400" dirty="0">
                 <a:solidFill>
                   <a:srgbClr val="434343">
@@ -18088,93 +17535,16 @@
                 <a:latin typeface="Meiryo UI" panose="020B0604030504040204" pitchFamily="34" charset="-128"/>
                 <a:ea typeface="Meiryo UI" panose="020B0604030504040204" pitchFamily="34" charset="-128"/>
               </a:rPr>
-              <a:t>Self Test Report</a:t>
-            </a:r>
-          </a:p>
-        </p:txBody>
-      </p:sp>
-      <p:sp>
-        <p:nvSpPr>
-          <p:cNvPr id="2" name="文本框 1">
-            <a:extLst>
-              <a:ext uri="{FF2B5EF4-FFF2-40B4-BE49-F238E27FC236}">
-                <a16:creationId xmlns:a16="http://schemas.microsoft.com/office/drawing/2014/main" id="{98AA5B65-BF3C-37BA-BBFF-E961FA80168C}"/>
-              </a:ext>
-            </a:extLst>
-          </p:cNvPr>
-          <p:cNvSpPr txBox="1"/>
-          <p:nvPr/>
-        </p:nvSpPr>
-        <p:spPr>
-          <a:xfrm>
-            <a:off x="649605" y="1277620"/>
-            <a:ext cx="1700787" cy="1087477"/>
-          </a:xfrm>
-          <a:prstGeom prst="rect">
-            <a:avLst/>
-          </a:prstGeom>
-          <a:noFill/>
-          <a:ln w="12700" cap="flat">
-            <a:noFill/>
-            <a:miter lim="400000"/>
-          </a:ln>
-        </p:spPr>
-        <p:style>
-          <a:lnRef idx="0">
-            <a:scrgbClr r="0" g="0" b="0"/>
-          </a:lnRef>
-          <a:fillRef idx="0">
-            <a:scrgbClr r="0" g="0" b="0"/>
-          </a:fillRef>
-          <a:effectRef idx="0">
-            <a:scrgbClr r="0" g="0" b="0"/>
-          </a:effectRef>
-          <a:fontRef idx="none"/>
-        </p:style>
-        <p:txBody>
-          <a:bodyPr rot="0" vertOverflow="overflow" horzOverflow="overflow" vert="horz" wrap="none" lIns="50800" tIns="50800" rIns="50800" bIns="50800" numCol="1" spcCol="38100" rtlCol="0" anchor="t" forceAA="0">
-            <a:spAutoFit/>
-          </a:bodyPr>
-          <a:lstStyle/>
-          <a:p>
-            <a:pPr lvl="0" algn="l">
-              <a:defRPr/>
-            </a:pPr>
-            <a:r>
-              <a:rPr lang="en-US" altLang="zh-CN" sz="6400">
-                <a:solidFill>
-                  <a:srgbClr val="434343">
-                    <a:lumMod val="50000"/>
-                  </a:srgbClr>
-                </a:solidFill>
-                <a:latin typeface="Meiryo UI" panose="020B0604030504040204" pitchFamily="34" charset="-128"/>
-                <a:ea typeface="Meiryo UI" panose="020B0604030504040204" pitchFamily="34" charset="-128"/>
-              </a:rPr>
-              <a:t>TBT</a:t>
-            </a:r>
-            <a:endParaRPr lang="en-US" altLang="zh-CN" sz="6400" dirty="0">
-              <a:solidFill>
-                <a:srgbClr val="434343">
-                  <a:lumMod val="50000"/>
-                </a:srgbClr>
-              </a:solidFill>
-              <a:latin typeface="Meiryo UI" panose="020B0604030504040204" pitchFamily="34" charset="-128"/>
-              <a:ea typeface="Meiryo UI" panose="020B0604030504040204" pitchFamily="34" charset="-128"/>
-            </a:endParaRPr>
+              <a:t/>
+            </a:r>
           </a:p>
         </p:txBody>
       </p:sp>
     </p:spTree>
-    <p:extLst>
-      <p:ext uri="{BB962C8B-B14F-4D97-AF65-F5344CB8AC3E}">
-        <p14:creationId xmlns:p14="http://schemas.microsoft.com/office/powerpoint/2010/main" val="1037475528"/>
-      </p:ext>
-    </p:extLst>
   </p:cSld>
   <p:clrMapOvr>
     <a:masterClrMapping/>
   </p:clrMapOvr>
-  <p:transition spd="med"/>
 </p:sld>
 </file>
 

</xml_diff>